<commit_message>
Add clinical imperative to technical deck
Co-authored-by: Shyam <shyam.nexus@gmail.com>
</commit_message>
<xml_diff>
--- a/India_APAC_Innovation_Challenge_Phase2_Technical_Architecture_Version.pptx
+++ b/India_APAC_Innovation_Challenge_Phase2_Technical_Architecture_Version.pptx
@@ -14228,7 +14228,7 @@
               </a:defRPr>
             </a:pPr>
             <a:r>
-              <a:t>Rules for trends, thresholds, missed vitals, battery, connectivity</a:t>
+              <a:t>Risk scores, trends, thresholds, missed vitals, battery, connectivity</a:t>
             </a:r>
           </a:p>
         </p:txBody>
@@ -14677,7 +14677,7 @@
               </a:defRPr>
             </a:pPr>
             <a:r>
-              <a:t>Demo story: sensor signal becomes operational action and measurable KPI</a:t>
+              <a:t>Demo story: sensor signal becomes risk score, clinical action, and measurable outcome</a:t>
             </a:r>
           </a:p>
         </p:txBody>
@@ -15635,7 +15635,7 @@
               </a:defRPr>
             </a:pPr>
             <a:r>
-              <a:t>Honeywell extends the wearable smart patch into a hospital-grade connected-care architecture spanning sensing, edge, interoperability, workflow intelligence, and command-center operations.</a:t>
+              <a:t>Clinical imperative: world-class hospitals can save patients when they reach the intervention team in time. Honeywell creates that time window through continuous risk scoring, deterioration prediction, and faster escalation.</a:t>
             </a:r>
           </a:p>
         </p:txBody>
@@ -16340,7 +16340,7 @@
               </a:defRPr>
             </a:pPr>
             <a:r>
-              <a:t>Technical objective: one event-driven hospital operating layer</a:t>
+              <a:t>Clinical objective: monitor risk continuously, predict attacks earlier, and help save lives</a:t>
             </a:r>
           </a:p>
         </p:txBody>

</xml_diff>

<commit_message>
Highlight Wearable Smart Patch achievements
Co-authored-by: Shyam <shyam.nexus@gmail.com>
</commit_message>
<xml_diff>
--- a/India_APAC_Innovation_Challenge_Phase2_Technical_Architecture_Version.pptx
+++ b/India_APAC_Innovation_Challenge_Phase2_Technical_Architecture_Version.pptx
@@ -23,6 +23,7 @@
     <p:sldId id="271" r:id="rId22"/>
     <p:sldId id="272" r:id="rId23"/>
     <p:sldId id="273" r:id="rId24"/>
+    <p:sldId id="274" r:id="rId25"/>
   </p:sldIdLst>
   <p:sldSz cx="12191695" cy="6858000" type="screen4x3"/>
   <p:notesSz cx="6858000" cy="9144000"/>
@@ -15241,6 +15242,1817 @@
 </p:sld>
 </file>
 
+<file path=ppt/slides/slide19.xml><?xml version="1.0" encoding="utf-8"?>
+<p:sld xmlns:a="http://schemas.openxmlformats.org/drawingml/2006/main" xmlns:p="http://schemas.openxmlformats.org/presentationml/2006/main" xmlns:r="http://schemas.openxmlformats.org/officeDocument/2006/relationships">
+  <p:cSld>
+    <p:bg>
+      <p:bgPr>
+        <a:solidFill>
+          <a:srgbClr val="FFFFFF"/>
+        </a:solidFill>
+        <a:effectLst/>
+      </p:bgPr>
+    </p:bg>
+    <p:spTree>
+      <p:nvGrpSpPr>
+        <p:cNvPr id="1" name=""/>
+        <p:cNvGrpSpPr/>
+        <p:nvPr/>
+      </p:nvGrpSpPr>
+      <p:grpSpPr/>
+      <p:sp>
+        <p:nvSpPr>
+          <p:cNvPr id="2" name="Rectangle 1"/>
+          <p:cNvSpPr/>
+          <p:nvPr/>
+        </p:nvSpPr>
+        <p:spPr>
+          <a:xfrm>
+            <a:off x="0" y="0"/>
+            <a:ext cx="12191695" cy="621792"/>
+          </a:xfrm>
+          <a:prstGeom prst="rect">
+            <a:avLst/>
+          </a:prstGeom>
+          <a:solidFill>
+            <a:srgbClr val="FFFFFF"/>
+          </a:solidFill>
+          <a:ln>
+            <a:noFill/>
+          </a:ln>
+        </p:spPr>
+        <p:style>
+          <a:lnRef idx="1">
+            <a:schemeClr val="accent1"/>
+          </a:lnRef>
+          <a:fillRef idx="3">
+            <a:schemeClr val="accent1"/>
+          </a:fillRef>
+          <a:effectRef idx="2">
+            <a:schemeClr val="accent1"/>
+          </a:effectRef>
+          <a:fontRef idx="minor">
+            <a:schemeClr val="lt1"/>
+          </a:fontRef>
+        </p:style>
+        <p:txBody>
+          <a:bodyPr rtlCol="0" anchor="ctr"/>
+          <a:lstStyle/>
+          <a:p>
+            <a:pPr algn="ctr"/>
+          </a:p>
+        </p:txBody>
+      </p:sp>
+      <p:sp>
+        <p:nvSpPr>
+          <p:cNvPr id="3" name="Rectangle 2"/>
+          <p:cNvSpPr/>
+          <p:nvPr/>
+        </p:nvSpPr>
+        <p:spPr>
+          <a:xfrm>
+            <a:off x="0" y="621792"/>
+            <a:ext cx="12191695" cy="54864"/>
+          </a:xfrm>
+          <a:prstGeom prst="rect">
+            <a:avLst/>
+          </a:prstGeom>
+          <a:solidFill>
+            <a:srgbClr val="E4002B"/>
+          </a:solidFill>
+          <a:ln>
+            <a:noFill/>
+          </a:ln>
+        </p:spPr>
+        <p:style>
+          <a:lnRef idx="1">
+            <a:schemeClr val="accent1"/>
+          </a:lnRef>
+          <a:fillRef idx="3">
+            <a:schemeClr val="accent1"/>
+          </a:fillRef>
+          <a:effectRef idx="2">
+            <a:schemeClr val="accent1"/>
+          </a:effectRef>
+          <a:fontRef idx="minor">
+            <a:schemeClr val="lt1"/>
+          </a:fontRef>
+        </p:style>
+        <p:txBody>
+          <a:bodyPr rtlCol="0" anchor="ctr"/>
+          <a:lstStyle/>
+          <a:p>
+            <a:pPr algn="ctr"/>
+          </a:p>
+        </p:txBody>
+      </p:sp>
+      <p:sp>
+        <p:nvSpPr>
+          <p:cNvPr id="4" name="TextBox 3"/>
+          <p:cNvSpPr txBox="1"/>
+          <p:nvPr/>
+        </p:nvSpPr>
+        <p:spPr>
+          <a:xfrm>
+            <a:off x="475488" y="201168"/>
+            <a:ext cx="1691640" cy="292608"/>
+          </a:xfrm>
+          <a:prstGeom prst="rect">
+            <a:avLst/>
+          </a:prstGeom>
+          <a:noFill/>
+        </p:spPr>
+        <p:txBody>
+          <a:bodyPr wrap="square" lIns="36576" rIns="36576" tIns="18288" bIns="18288">
+            <a:spAutoFit/>
+          </a:bodyPr>
+          <a:lstStyle/>
+          <a:p>
+            <a:pPr>
+              <a:defRPr sz="1800" b="1">
+                <a:solidFill>
+                  <a:srgbClr val="E4002B"/>
+                </a:solidFill>
+                <a:latin typeface="Arial"/>
+              </a:defRPr>
+            </a:pPr>
+            <a:r>
+              <a:t>Honeywell</a:t>
+            </a:r>
+          </a:p>
+        </p:txBody>
+      </p:sp>
+      <p:sp>
+        <p:nvSpPr>
+          <p:cNvPr id="5" name="TextBox 4"/>
+          <p:cNvSpPr txBox="1"/>
+          <p:nvPr/>
+        </p:nvSpPr>
+        <p:spPr>
+          <a:xfrm>
+            <a:off x="2148840" y="164592"/>
+            <a:ext cx="7132320" cy="347472"/>
+          </a:xfrm>
+          <a:prstGeom prst="rect">
+            <a:avLst/>
+          </a:prstGeom>
+          <a:noFill/>
+        </p:spPr>
+        <p:txBody>
+          <a:bodyPr wrap="square" lIns="36576" rIns="36576" tIns="18288" bIns="18288">
+            <a:spAutoFit/>
+          </a:bodyPr>
+          <a:lstStyle/>
+          <a:p>
+            <a:pPr>
+              <a:defRPr sz="1800" b="1">
+                <a:solidFill>
+                  <a:srgbClr val="202020"/>
+                </a:solidFill>
+                <a:latin typeface="Arial"/>
+              </a:defRPr>
+            </a:pPr>
+            <a:r>
+              <a:t>What we have already achieved</a:t>
+            </a:r>
+          </a:p>
+        </p:txBody>
+      </p:sp>
+      <p:sp>
+        <p:nvSpPr>
+          <p:cNvPr id="6" name="TextBox 5"/>
+          <p:cNvSpPr txBox="1"/>
+          <p:nvPr/>
+        </p:nvSpPr>
+        <p:spPr>
+          <a:xfrm>
+            <a:off x="9098280" y="182880"/>
+            <a:ext cx="2560320" cy="274320"/>
+          </a:xfrm>
+          <a:prstGeom prst="rect">
+            <a:avLst/>
+          </a:prstGeom>
+          <a:noFill/>
+        </p:spPr>
+        <p:txBody>
+          <a:bodyPr wrap="square" lIns="36576" rIns="36576" tIns="18288" bIns="18288">
+            <a:spAutoFit/>
+          </a:bodyPr>
+          <a:lstStyle/>
+          <a:p>
+            <a:pPr algn="r">
+              <a:defRPr sz="850" b="0">
+                <a:solidFill>
+                  <a:srgbClr val="63666A"/>
+                </a:solidFill>
+                <a:latin typeface="Arial"/>
+              </a:defRPr>
+            </a:pPr>
+            <a:r>
+              <a:t>Wearable Smart Patch</a:t>
+            </a:r>
+          </a:p>
+        </p:txBody>
+      </p:sp>
+      <p:sp>
+        <p:nvSpPr>
+          <p:cNvPr id="7" name="Rectangle 6"/>
+          <p:cNvSpPr/>
+          <p:nvPr/>
+        </p:nvSpPr>
+        <p:spPr>
+          <a:xfrm>
+            <a:off x="594360" y="1024128"/>
+            <a:ext cx="3364992" cy="1170432"/>
+          </a:xfrm>
+          <a:prstGeom prst="rect">
+            <a:avLst/>
+          </a:prstGeom>
+          <a:solidFill>
+            <a:srgbClr val="F3F4F6"/>
+          </a:solidFill>
+          <a:ln w="9525">
+            <a:solidFill>
+              <a:srgbClr val="E8EBEF"/>
+            </a:solidFill>
+          </a:ln>
+        </p:spPr>
+        <p:style>
+          <a:lnRef idx="1">
+            <a:schemeClr val="accent1"/>
+          </a:lnRef>
+          <a:fillRef idx="3">
+            <a:schemeClr val="accent1"/>
+          </a:fillRef>
+          <a:effectRef idx="2">
+            <a:schemeClr val="accent1"/>
+          </a:effectRef>
+          <a:fontRef idx="minor">
+            <a:schemeClr val="lt1"/>
+          </a:fontRef>
+        </p:style>
+        <p:txBody>
+          <a:bodyPr rtlCol="0" anchor="ctr"/>
+          <a:lstStyle/>
+          <a:p>
+            <a:pPr algn="ctr"/>
+          </a:p>
+        </p:txBody>
+      </p:sp>
+      <p:sp>
+        <p:nvSpPr>
+          <p:cNvPr id="8" name="Rectangle 7"/>
+          <p:cNvSpPr/>
+          <p:nvPr/>
+        </p:nvSpPr>
+        <p:spPr>
+          <a:xfrm>
+            <a:off x="594360" y="1024128"/>
+            <a:ext cx="73152" cy="1170432"/>
+          </a:xfrm>
+          <a:prstGeom prst="rect">
+            <a:avLst/>
+          </a:prstGeom>
+          <a:solidFill>
+            <a:srgbClr val="E4002B"/>
+          </a:solidFill>
+          <a:ln>
+            <a:noFill/>
+          </a:ln>
+        </p:spPr>
+        <p:style>
+          <a:lnRef idx="1">
+            <a:schemeClr val="accent1"/>
+          </a:lnRef>
+          <a:fillRef idx="3">
+            <a:schemeClr val="accent1"/>
+          </a:fillRef>
+          <a:effectRef idx="2">
+            <a:schemeClr val="accent1"/>
+          </a:effectRef>
+          <a:fontRef idx="minor">
+            <a:schemeClr val="lt1"/>
+          </a:fontRef>
+        </p:style>
+        <p:txBody>
+          <a:bodyPr rtlCol="0" anchor="ctr"/>
+          <a:lstStyle/>
+          <a:p>
+            <a:pPr algn="ctr"/>
+          </a:p>
+        </p:txBody>
+      </p:sp>
+      <p:sp>
+        <p:nvSpPr>
+          <p:cNvPr id="9" name="TextBox 8"/>
+          <p:cNvSpPr txBox="1"/>
+          <p:nvPr/>
+        </p:nvSpPr>
+        <p:spPr>
+          <a:xfrm>
+            <a:off x="777240" y="1133856"/>
+            <a:ext cx="3072384" cy="256032"/>
+          </a:xfrm>
+          <a:prstGeom prst="rect">
+            <a:avLst/>
+          </a:prstGeom>
+          <a:noFill/>
+        </p:spPr>
+        <p:txBody>
+          <a:bodyPr wrap="square" lIns="36576" rIns="36576" tIns="18288" bIns="18288">
+            <a:spAutoFit/>
+          </a:bodyPr>
+          <a:lstStyle/>
+          <a:p>
+            <a:pPr>
+              <a:defRPr sz="1130" b="1">
+                <a:solidFill>
+                  <a:srgbClr val="202020"/>
+                </a:solidFill>
+                <a:latin typeface="Arial"/>
+              </a:defRPr>
+            </a:pPr>
+            <a:r>
+              <a:t>Clinical scope defined</a:t>
+            </a:r>
+          </a:p>
+        </p:txBody>
+      </p:sp>
+      <p:sp>
+        <p:nvSpPr>
+          <p:cNvPr id="10" name="TextBox 9"/>
+          <p:cNvSpPr txBox="1"/>
+          <p:nvPr/>
+        </p:nvSpPr>
+        <p:spPr>
+          <a:xfrm>
+            <a:off x="777240" y="1453896"/>
+            <a:ext cx="3054096" cy="685800"/>
+          </a:xfrm>
+          <a:prstGeom prst="rect">
+            <a:avLst/>
+          </a:prstGeom>
+          <a:noFill/>
+        </p:spPr>
+        <p:txBody>
+          <a:bodyPr wrap="square" lIns="0" rIns="18288" tIns="0">
+            <a:spAutoFit/>
+          </a:bodyPr>
+          <a:lstStyle/>
+          <a:p>
+            <a:pPr>
+              <a:defRPr sz="940">
+                <a:solidFill>
+                  <a:srgbClr val="36393F"/>
+                </a:solidFill>
+                <a:latin typeface="Arial"/>
+              </a:defRPr>
+            </a:pPr>
+            <a:r>
+              <a:t>ECG, heart rate, skin temperature, respiration, posture, restlessness, SpO2 expansion, connected vitals workflows.</a:t>
+            </a:r>
+          </a:p>
+        </p:txBody>
+      </p:sp>
+      <p:sp>
+        <p:nvSpPr>
+          <p:cNvPr id="11" name="Rectangle 10"/>
+          <p:cNvSpPr/>
+          <p:nvPr/>
+        </p:nvSpPr>
+        <p:spPr>
+          <a:xfrm>
+            <a:off x="4389120" y="1024128"/>
+            <a:ext cx="3364992" cy="1170432"/>
+          </a:xfrm>
+          <a:prstGeom prst="rect">
+            <a:avLst/>
+          </a:prstGeom>
+          <a:solidFill>
+            <a:srgbClr val="F3F4F6"/>
+          </a:solidFill>
+          <a:ln w="9525">
+            <a:solidFill>
+              <a:srgbClr val="E8EBEF"/>
+            </a:solidFill>
+          </a:ln>
+        </p:spPr>
+        <p:style>
+          <a:lnRef idx="1">
+            <a:schemeClr val="accent1"/>
+          </a:lnRef>
+          <a:fillRef idx="3">
+            <a:schemeClr val="accent1"/>
+          </a:fillRef>
+          <a:effectRef idx="2">
+            <a:schemeClr val="accent1"/>
+          </a:effectRef>
+          <a:fontRef idx="minor">
+            <a:schemeClr val="lt1"/>
+          </a:fontRef>
+        </p:style>
+        <p:txBody>
+          <a:bodyPr rtlCol="0" anchor="ctr"/>
+          <a:lstStyle/>
+          <a:p>
+            <a:pPr algn="ctr"/>
+          </a:p>
+        </p:txBody>
+      </p:sp>
+      <p:sp>
+        <p:nvSpPr>
+          <p:cNvPr id="12" name="Rectangle 11"/>
+          <p:cNvSpPr/>
+          <p:nvPr/>
+        </p:nvSpPr>
+        <p:spPr>
+          <a:xfrm>
+            <a:off x="4389120" y="1024128"/>
+            <a:ext cx="73152" cy="1170432"/>
+          </a:xfrm>
+          <a:prstGeom prst="rect">
+            <a:avLst/>
+          </a:prstGeom>
+          <a:solidFill>
+            <a:srgbClr val="202020"/>
+          </a:solidFill>
+          <a:ln>
+            <a:noFill/>
+          </a:ln>
+        </p:spPr>
+        <p:style>
+          <a:lnRef idx="1">
+            <a:schemeClr val="accent1"/>
+          </a:lnRef>
+          <a:fillRef idx="3">
+            <a:schemeClr val="accent1"/>
+          </a:fillRef>
+          <a:effectRef idx="2">
+            <a:schemeClr val="accent1"/>
+          </a:effectRef>
+          <a:fontRef idx="minor">
+            <a:schemeClr val="lt1"/>
+          </a:fontRef>
+        </p:style>
+        <p:txBody>
+          <a:bodyPr rtlCol="0" anchor="ctr"/>
+          <a:lstStyle/>
+          <a:p>
+            <a:pPr algn="ctr"/>
+          </a:p>
+        </p:txBody>
+      </p:sp>
+      <p:sp>
+        <p:nvSpPr>
+          <p:cNvPr id="13" name="TextBox 12"/>
+          <p:cNvSpPr txBox="1"/>
+          <p:nvPr/>
+        </p:nvSpPr>
+        <p:spPr>
+          <a:xfrm>
+            <a:off x="4572000" y="1133856"/>
+            <a:ext cx="3072384" cy="256032"/>
+          </a:xfrm>
+          <a:prstGeom prst="rect">
+            <a:avLst/>
+          </a:prstGeom>
+          <a:noFill/>
+        </p:spPr>
+        <p:txBody>
+          <a:bodyPr wrap="square" lIns="36576" rIns="36576" tIns="18288" bIns="18288">
+            <a:spAutoFit/>
+          </a:bodyPr>
+          <a:lstStyle/>
+          <a:p>
+            <a:pPr>
+              <a:defRPr sz="1130" b="1">
+                <a:solidFill>
+                  <a:srgbClr val="202020"/>
+                </a:solidFill>
+                <a:latin typeface="Arial"/>
+              </a:defRPr>
+            </a:pPr>
+            <a:r>
+              <a:t>MVO1 requirements captured</a:t>
+            </a:r>
+          </a:p>
+        </p:txBody>
+      </p:sp>
+      <p:sp>
+        <p:nvSpPr>
+          <p:cNvPr id="14" name="TextBox 13"/>
+          <p:cNvSpPr txBox="1"/>
+          <p:nvPr/>
+        </p:nvSpPr>
+        <p:spPr>
+          <a:xfrm>
+            <a:off x="4572000" y="1453896"/>
+            <a:ext cx="3054096" cy="685800"/>
+          </a:xfrm>
+          <a:prstGeom prst="rect">
+            <a:avLst/>
+          </a:prstGeom>
+          <a:noFill/>
+        </p:spPr>
+        <p:txBody>
+          <a:bodyPr wrap="square" lIns="0" rIns="18288" tIns="0">
+            <a:spAutoFit/>
+          </a:bodyPr>
+          <a:lstStyle/>
+          <a:p>
+            <a:pPr>
+              <a:defRPr sz="940">
+                <a:solidFill>
+                  <a:srgbClr val="36393F"/>
+                </a:solidFill>
+                <a:latin typeface="Arial"/>
+              </a:defRPr>
+            </a:pPr>
+            <a:r>
+              <a:t>Narayana Hrudayalaya business overview, reusable rechargeable device, periodic telemetry, API endpoint direction.</a:t>
+            </a:r>
+          </a:p>
+        </p:txBody>
+      </p:sp>
+      <p:sp>
+        <p:nvSpPr>
+          <p:cNvPr id="15" name="Rectangle 14"/>
+          <p:cNvSpPr/>
+          <p:nvPr/>
+        </p:nvSpPr>
+        <p:spPr>
+          <a:xfrm>
+            <a:off x="8183880" y="1024128"/>
+            <a:ext cx="3364992" cy="1170432"/>
+          </a:xfrm>
+          <a:prstGeom prst="rect">
+            <a:avLst/>
+          </a:prstGeom>
+          <a:solidFill>
+            <a:srgbClr val="F3F4F6"/>
+          </a:solidFill>
+          <a:ln w="9525">
+            <a:solidFill>
+              <a:srgbClr val="E8EBEF"/>
+            </a:solidFill>
+          </a:ln>
+        </p:spPr>
+        <p:style>
+          <a:lnRef idx="1">
+            <a:schemeClr val="accent1"/>
+          </a:lnRef>
+          <a:fillRef idx="3">
+            <a:schemeClr val="accent1"/>
+          </a:fillRef>
+          <a:effectRef idx="2">
+            <a:schemeClr val="accent1"/>
+          </a:effectRef>
+          <a:fontRef idx="minor">
+            <a:schemeClr val="lt1"/>
+          </a:fontRef>
+        </p:style>
+        <p:txBody>
+          <a:bodyPr rtlCol="0" anchor="ctr"/>
+          <a:lstStyle/>
+          <a:p>
+            <a:pPr algn="ctr"/>
+          </a:p>
+        </p:txBody>
+      </p:sp>
+      <p:sp>
+        <p:nvSpPr>
+          <p:cNvPr id="16" name="Rectangle 15"/>
+          <p:cNvSpPr/>
+          <p:nvPr/>
+        </p:nvSpPr>
+        <p:spPr>
+          <a:xfrm>
+            <a:off x="8183880" y="1024128"/>
+            <a:ext cx="73152" cy="1170432"/>
+          </a:xfrm>
+          <a:prstGeom prst="rect">
+            <a:avLst/>
+          </a:prstGeom>
+          <a:solidFill>
+            <a:srgbClr val="E4002B"/>
+          </a:solidFill>
+          <a:ln>
+            <a:noFill/>
+          </a:ln>
+        </p:spPr>
+        <p:style>
+          <a:lnRef idx="1">
+            <a:schemeClr val="accent1"/>
+          </a:lnRef>
+          <a:fillRef idx="3">
+            <a:schemeClr val="accent1"/>
+          </a:fillRef>
+          <a:effectRef idx="2">
+            <a:schemeClr val="accent1"/>
+          </a:effectRef>
+          <a:fontRef idx="minor">
+            <a:schemeClr val="lt1"/>
+          </a:fontRef>
+        </p:style>
+        <p:txBody>
+          <a:bodyPr rtlCol="0" anchor="ctr"/>
+          <a:lstStyle/>
+          <a:p>
+            <a:pPr algn="ctr"/>
+          </a:p>
+        </p:txBody>
+      </p:sp>
+      <p:sp>
+        <p:nvSpPr>
+          <p:cNvPr id="17" name="TextBox 16"/>
+          <p:cNvSpPr txBox="1"/>
+          <p:nvPr/>
+        </p:nvSpPr>
+        <p:spPr>
+          <a:xfrm>
+            <a:off x="8366760" y="1133856"/>
+            <a:ext cx="3072384" cy="256032"/>
+          </a:xfrm>
+          <a:prstGeom prst="rect">
+            <a:avLst/>
+          </a:prstGeom>
+          <a:noFill/>
+        </p:spPr>
+        <p:txBody>
+          <a:bodyPr wrap="square" lIns="36576" rIns="36576" tIns="18288" bIns="18288">
+            <a:spAutoFit/>
+          </a:bodyPr>
+          <a:lstStyle/>
+          <a:p>
+            <a:pPr>
+              <a:defRPr sz="1130" b="1">
+                <a:solidFill>
+                  <a:srgbClr val="202020"/>
+                </a:solidFill>
+                <a:latin typeface="Arial"/>
+              </a:defRPr>
+            </a:pPr>
+            <a:r>
+              <a:t>Prototype and concepts created</a:t>
+            </a:r>
+          </a:p>
+        </p:txBody>
+      </p:sp>
+      <p:sp>
+        <p:nvSpPr>
+          <p:cNvPr id="18" name="TextBox 17"/>
+          <p:cNvSpPr txBox="1"/>
+          <p:nvPr/>
+        </p:nvSpPr>
+        <p:spPr>
+          <a:xfrm>
+            <a:off x="8366760" y="1453896"/>
+            <a:ext cx="3054096" cy="685800"/>
+          </a:xfrm>
+          <a:prstGeom prst="rect">
+            <a:avLst/>
+          </a:prstGeom>
+          <a:noFill/>
+        </p:spPr>
+        <p:txBody>
+          <a:bodyPr wrap="square" lIns="0" rIns="18288" tIns="0">
+            <a:spAutoFit/>
+          </a:bodyPr>
+          <a:lstStyle/>
+          <a:p>
+            <a:pPr>
+              <a:defRPr sz="940">
+                <a:solidFill>
+                  <a:srgbClr val="36393F"/>
+                </a:solidFill>
+                <a:latin typeface="Arial"/>
+              </a:defRPr>
+            </a:pPr>
+            <a:r>
+              <a:t>Industrial design renders, POC visuals, electrode placement, ECG cable options, USB-C interface, enclosure concepts.</a:t>
+            </a:r>
+          </a:p>
+        </p:txBody>
+      </p:sp>
+      <p:sp>
+        <p:nvSpPr>
+          <p:cNvPr id="19" name="Rectangle 18"/>
+          <p:cNvSpPr/>
+          <p:nvPr/>
+        </p:nvSpPr>
+        <p:spPr>
+          <a:xfrm>
+            <a:off x="594360" y="2596896"/>
+            <a:ext cx="3364992" cy="1170432"/>
+          </a:xfrm>
+          <a:prstGeom prst="rect">
+            <a:avLst/>
+          </a:prstGeom>
+          <a:solidFill>
+            <a:srgbClr val="F3F4F6"/>
+          </a:solidFill>
+          <a:ln w="9525">
+            <a:solidFill>
+              <a:srgbClr val="E8EBEF"/>
+            </a:solidFill>
+          </a:ln>
+        </p:spPr>
+        <p:style>
+          <a:lnRef idx="1">
+            <a:schemeClr val="accent1"/>
+          </a:lnRef>
+          <a:fillRef idx="3">
+            <a:schemeClr val="accent1"/>
+          </a:fillRef>
+          <a:effectRef idx="2">
+            <a:schemeClr val="accent1"/>
+          </a:effectRef>
+          <a:fontRef idx="minor">
+            <a:schemeClr val="lt1"/>
+          </a:fontRef>
+        </p:style>
+        <p:txBody>
+          <a:bodyPr rtlCol="0" anchor="ctr"/>
+          <a:lstStyle/>
+          <a:p>
+            <a:pPr algn="ctr"/>
+          </a:p>
+        </p:txBody>
+      </p:sp>
+      <p:sp>
+        <p:nvSpPr>
+          <p:cNvPr id="20" name="Rectangle 19"/>
+          <p:cNvSpPr/>
+          <p:nvPr/>
+        </p:nvSpPr>
+        <p:spPr>
+          <a:xfrm>
+            <a:off x="594360" y="2596896"/>
+            <a:ext cx="73152" cy="1170432"/>
+          </a:xfrm>
+          <a:prstGeom prst="rect">
+            <a:avLst/>
+          </a:prstGeom>
+          <a:solidFill>
+            <a:srgbClr val="202020"/>
+          </a:solidFill>
+          <a:ln>
+            <a:noFill/>
+          </a:ln>
+        </p:spPr>
+        <p:style>
+          <a:lnRef idx="1">
+            <a:schemeClr val="accent1"/>
+          </a:lnRef>
+          <a:fillRef idx="3">
+            <a:schemeClr val="accent1"/>
+          </a:fillRef>
+          <a:effectRef idx="2">
+            <a:schemeClr val="accent1"/>
+          </a:effectRef>
+          <a:fontRef idx="minor">
+            <a:schemeClr val="lt1"/>
+          </a:fontRef>
+        </p:style>
+        <p:txBody>
+          <a:bodyPr rtlCol="0" anchor="ctr"/>
+          <a:lstStyle/>
+          <a:p>
+            <a:pPr algn="ctr"/>
+          </a:p>
+        </p:txBody>
+      </p:sp>
+      <p:sp>
+        <p:nvSpPr>
+          <p:cNvPr id="21" name="TextBox 20"/>
+          <p:cNvSpPr txBox="1"/>
+          <p:nvPr/>
+        </p:nvSpPr>
+        <p:spPr>
+          <a:xfrm>
+            <a:off x="777240" y="2706624"/>
+            <a:ext cx="3072384" cy="256032"/>
+          </a:xfrm>
+          <a:prstGeom prst="rect">
+            <a:avLst/>
+          </a:prstGeom>
+          <a:noFill/>
+        </p:spPr>
+        <p:txBody>
+          <a:bodyPr wrap="square" lIns="36576" rIns="36576" tIns="18288" bIns="18288">
+            <a:spAutoFit/>
+          </a:bodyPr>
+          <a:lstStyle/>
+          <a:p>
+            <a:pPr>
+              <a:defRPr sz="1130" b="1">
+                <a:solidFill>
+                  <a:srgbClr val="202020"/>
+                </a:solidFill>
+                <a:latin typeface="Arial"/>
+              </a:defRPr>
+            </a:pPr>
+            <a:r>
+              <a:t>Hardware baseline developed</a:t>
+            </a:r>
+          </a:p>
+        </p:txBody>
+      </p:sp>
+      <p:sp>
+        <p:nvSpPr>
+          <p:cNvPr id="22" name="TextBox 21"/>
+          <p:cNvSpPr txBox="1"/>
+          <p:nvPr/>
+        </p:nvSpPr>
+        <p:spPr>
+          <a:xfrm>
+            <a:off x="777240" y="3026663"/>
+            <a:ext cx="3054096" cy="685800"/>
+          </a:xfrm>
+          <a:prstGeom prst="rect">
+            <a:avLst/>
+          </a:prstGeom>
+          <a:noFill/>
+        </p:spPr>
+        <p:txBody>
+          <a:bodyPr wrap="square" lIns="0" rIns="18288" tIns="0">
+            <a:spAutoFit/>
+          </a:bodyPr>
+          <a:lstStyle/>
+          <a:p>
+            <a:pPr>
+              <a:defRPr sz="940">
+                <a:solidFill>
+                  <a:srgbClr val="36393F"/>
+                </a:solidFill>
+                <a:latin typeface="Arial"/>
+              </a:defRPr>
+            </a:pPr>
+            <a:r>
+              <a:t>ESP32-S3-MINI-1, MAX30003 ECG AFE, TMP1075, ADXL367, MAX20356 PMIC, Li-polymer battery, LED, debug support.</a:t>
+            </a:r>
+          </a:p>
+        </p:txBody>
+      </p:sp>
+      <p:sp>
+        <p:nvSpPr>
+          <p:cNvPr id="23" name="Rectangle 22"/>
+          <p:cNvSpPr/>
+          <p:nvPr/>
+        </p:nvSpPr>
+        <p:spPr>
+          <a:xfrm>
+            <a:off x="4389120" y="2596896"/>
+            <a:ext cx="3364992" cy="1170432"/>
+          </a:xfrm>
+          <a:prstGeom prst="rect">
+            <a:avLst/>
+          </a:prstGeom>
+          <a:solidFill>
+            <a:srgbClr val="F3F4F6"/>
+          </a:solidFill>
+          <a:ln w="9525">
+            <a:solidFill>
+              <a:srgbClr val="E8EBEF"/>
+            </a:solidFill>
+          </a:ln>
+        </p:spPr>
+        <p:style>
+          <a:lnRef idx="1">
+            <a:schemeClr val="accent1"/>
+          </a:lnRef>
+          <a:fillRef idx="3">
+            <a:schemeClr val="accent1"/>
+          </a:fillRef>
+          <a:effectRef idx="2">
+            <a:schemeClr val="accent1"/>
+          </a:effectRef>
+          <a:fontRef idx="minor">
+            <a:schemeClr val="lt1"/>
+          </a:fontRef>
+        </p:style>
+        <p:txBody>
+          <a:bodyPr rtlCol="0" anchor="ctr"/>
+          <a:lstStyle/>
+          <a:p>
+            <a:pPr algn="ctr"/>
+          </a:p>
+        </p:txBody>
+      </p:sp>
+      <p:sp>
+        <p:nvSpPr>
+          <p:cNvPr id="24" name="Rectangle 23"/>
+          <p:cNvSpPr/>
+          <p:nvPr/>
+        </p:nvSpPr>
+        <p:spPr>
+          <a:xfrm>
+            <a:off x="4389120" y="2596896"/>
+            <a:ext cx="73152" cy="1170432"/>
+          </a:xfrm>
+          <a:prstGeom prst="rect">
+            <a:avLst/>
+          </a:prstGeom>
+          <a:solidFill>
+            <a:srgbClr val="E4002B"/>
+          </a:solidFill>
+          <a:ln>
+            <a:noFill/>
+          </a:ln>
+        </p:spPr>
+        <p:style>
+          <a:lnRef idx="1">
+            <a:schemeClr val="accent1"/>
+          </a:lnRef>
+          <a:fillRef idx="3">
+            <a:schemeClr val="accent1"/>
+          </a:fillRef>
+          <a:effectRef idx="2">
+            <a:schemeClr val="accent1"/>
+          </a:effectRef>
+          <a:fontRef idx="minor">
+            <a:schemeClr val="lt1"/>
+          </a:fontRef>
+        </p:style>
+        <p:txBody>
+          <a:bodyPr rtlCol="0" anchor="ctr"/>
+          <a:lstStyle/>
+          <a:p>
+            <a:pPr algn="ctr"/>
+          </a:p>
+        </p:txBody>
+      </p:sp>
+      <p:sp>
+        <p:nvSpPr>
+          <p:cNvPr id="25" name="TextBox 24"/>
+          <p:cNvSpPr txBox="1"/>
+          <p:nvPr/>
+        </p:nvSpPr>
+        <p:spPr>
+          <a:xfrm>
+            <a:off x="4572000" y="2706624"/>
+            <a:ext cx="3072384" cy="256032"/>
+          </a:xfrm>
+          <a:prstGeom prst="rect">
+            <a:avLst/>
+          </a:prstGeom>
+          <a:noFill/>
+        </p:spPr>
+        <p:txBody>
+          <a:bodyPr wrap="square" lIns="36576" rIns="36576" tIns="18288" bIns="18288">
+            <a:spAutoFit/>
+          </a:bodyPr>
+          <a:lstStyle/>
+          <a:p>
+            <a:pPr>
+              <a:defRPr sz="1130" b="1">
+                <a:solidFill>
+                  <a:srgbClr val="202020"/>
+                </a:solidFill>
+                <a:latin typeface="Arial"/>
+              </a:defRPr>
+            </a:pPr>
+            <a:r>
+              <a:t>Deliverables identified</a:t>
+            </a:r>
+          </a:p>
+        </p:txBody>
+      </p:sp>
+      <p:sp>
+        <p:nvSpPr>
+          <p:cNvPr id="26" name="TextBox 25"/>
+          <p:cNvSpPr txBox="1"/>
+          <p:nvPr/>
+        </p:nvSpPr>
+        <p:spPr>
+          <a:xfrm>
+            <a:off x="4572000" y="3026663"/>
+            <a:ext cx="3054096" cy="685800"/>
+          </a:xfrm>
+          <a:prstGeom prst="rect">
+            <a:avLst/>
+          </a:prstGeom>
+          <a:noFill/>
+        </p:spPr>
+        <p:txBody>
+          <a:bodyPr wrap="square" lIns="0" rIns="18288" tIns="0">
+            <a:spAutoFit/>
+          </a:bodyPr>
+          <a:lstStyle/>
+          <a:p>
+            <a:pPr>
+              <a:defRPr sz="940">
+                <a:solidFill>
+                  <a:srgbClr val="36393F"/>
+                </a:solidFill>
+                <a:latin typeface="Arial"/>
+              </a:defRPr>
+            </a:pPr>
+            <a:r>
+              <a:t>Smart patch device, ECG-USB cable, adhesive samples, user manual, Type-C charger, ECG plotting utility.</a:t>
+            </a:r>
+          </a:p>
+        </p:txBody>
+      </p:sp>
+      <p:sp>
+        <p:nvSpPr>
+          <p:cNvPr id="27" name="Rectangle 26"/>
+          <p:cNvSpPr/>
+          <p:nvPr/>
+        </p:nvSpPr>
+        <p:spPr>
+          <a:xfrm>
+            <a:off x="8183880" y="2596896"/>
+            <a:ext cx="3364992" cy="1170432"/>
+          </a:xfrm>
+          <a:prstGeom prst="rect">
+            <a:avLst/>
+          </a:prstGeom>
+          <a:solidFill>
+            <a:srgbClr val="F3F4F6"/>
+          </a:solidFill>
+          <a:ln w="9525">
+            <a:solidFill>
+              <a:srgbClr val="E8EBEF"/>
+            </a:solidFill>
+          </a:ln>
+        </p:spPr>
+        <p:style>
+          <a:lnRef idx="1">
+            <a:schemeClr val="accent1"/>
+          </a:lnRef>
+          <a:fillRef idx="3">
+            <a:schemeClr val="accent1"/>
+          </a:fillRef>
+          <a:effectRef idx="2">
+            <a:schemeClr val="accent1"/>
+          </a:effectRef>
+          <a:fontRef idx="minor">
+            <a:schemeClr val="lt1"/>
+          </a:fontRef>
+        </p:style>
+        <p:txBody>
+          <a:bodyPr rtlCol="0" anchor="ctr"/>
+          <a:lstStyle/>
+          <a:p>
+            <a:pPr algn="ctr"/>
+          </a:p>
+        </p:txBody>
+      </p:sp>
+      <p:sp>
+        <p:nvSpPr>
+          <p:cNvPr id="28" name="Rectangle 27"/>
+          <p:cNvSpPr/>
+          <p:nvPr/>
+        </p:nvSpPr>
+        <p:spPr>
+          <a:xfrm>
+            <a:off x="8183880" y="2596896"/>
+            <a:ext cx="73152" cy="1170432"/>
+          </a:xfrm>
+          <a:prstGeom prst="rect">
+            <a:avLst/>
+          </a:prstGeom>
+          <a:solidFill>
+            <a:srgbClr val="202020"/>
+          </a:solidFill>
+          <a:ln>
+            <a:noFill/>
+          </a:ln>
+        </p:spPr>
+        <p:style>
+          <a:lnRef idx="1">
+            <a:schemeClr val="accent1"/>
+          </a:lnRef>
+          <a:fillRef idx="3">
+            <a:schemeClr val="accent1"/>
+          </a:fillRef>
+          <a:effectRef idx="2">
+            <a:schemeClr val="accent1"/>
+          </a:effectRef>
+          <a:fontRef idx="minor">
+            <a:schemeClr val="lt1"/>
+          </a:fontRef>
+        </p:style>
+        <p:txBody>
+          <a:bodyPr rtlCol="0" anchor="ctr"/>
+          <a:lstStyle/>
+          <a:p>
+            <a:pPr algn="ctr"/>
+          </a:p>
+        </p:txBody>
+      </p:sp>
+      <p:sp>
+        <p:nvSpPr>
+          <p:cNvPr id="29" name="TextBox 28"/>
+          <p:cNvSpPr txBox="1"/>
+          <p:nvPr/>
+        </p:nvSpPr>
+        <p:spPr>
+          <a:xfrm>
+            <a:off x="8366760" y="2706624"/>
+            <a:ext cx="3072384" cy="256032"/>
+          </a:xfrm>
+          <a:prstGeom prst="rect">
+            <a:avLst/>
+          </a:prstGeom>
+          <a:noFill/>
+        </p:spPr>
+        <p:txBody>
+          <a:bodyPr wrap="square" lIns="36576" rIns="36576" tIns="18288" bIns="18288">
+            <a:spAutoFit/>
+          </a:bodyPr>
+          <a:lstStyle/>
+          <a:p>
+            <a:pPr>
+              <a:defRPr sz="1130" b="1">
+                <a:solidFill>
+                  <a:srgbClr val="202020"/>
+                </a:solidFill>
+                <a:latin typeface="Arial"/>
+              </a:defRPr>
+            </a:pPr>
+            <a:r>
+              <a:t>Integration model mapped</a:t>
+            </a:r>
+          </a:p>
+        </p:txBody>
+      </p:sp>
+      <p:sp>
+        <p:nvSpPr>
+          <p:cNvPr id="30" name="TextBox 29"/>
+          <p:cNvSpPr txBox="1"/>
+          <p:nvPr/>
+        </p:nvSpPr>
+        <p:spPr>
+          <a:xfrm>
+            <a:off x="8366760" y="3026663"/>
+            <a:ext cx="3054096" cy="685800"/>
+          </a:xfrm>
+          <a:prstGeom prst="rect">
+            <a:avLst/>
+          </a:prstGeom>
+          <a:noFill/>
+        </p:spPr>
+        <p:txBody>
+          <a:bodyPr wrap="square" lIns="0" rIns="18288" tIns="0">
+            <a:spAutoFit/>
+          </a:bodyPr>
+          <a:lstStyle/>
+          <a:p>
+            <a:pPr>
+              <a:defRPr sz="940">
+                <a:solidFill>
+                  <a:srgbClr val="36393F"/>
+                </a:solidFill>
+                <a:latin typeface="Arial"/>
+              </a:defRPr>
+            </a:pPr>
+            <a:r>
+              <a:t>Honeywell hardware/firmware/backend responsibilities and NH API, HMS/patient-ID, reporting, alerts, validation roles.</a:t>
+            </a:r>
+          </a:p>
+        </p:txBody>
+      </p:sp>
+      <p:sp>
+        <p:nvSpPr>
+          <p:cNvPr id="31" name="Rectangle 30"/>
+          <p:cNvSpPr/>
+          <p:nvPr/>
+        </p:nvSpPr>
+        <p:spPr>
+          <a:xfrm>
+            <a:off x="594360" y="4169664"/>
+            <a:ext cx="3364992" cy="1170432"/>
+          </a:xfrm>
+          <a:prstGeom prst="rect">
+            <a:avLst/>
+          </a:prstGeom>
+          <a:solidFill>
+            <a:srgbClr val="F3F4F6"/>
+          </a:solidFill>
+          <a:ln w="9525">
+            <a:solidFill>
+              <a:srgbClr val="E8EBEF"/>
+            </a:solidFill>
+          </a:ln>
+        </p:spPr>
+        <p:style>
+          <a:lnRef idx="1">
+            <a:schemeClr val="accent1"/>
+          </a:lnRef>
+          <a:fillRef idx="3">
+            <a:schemeClr val="accent1"/>
+          </a:fillRef>
+          <a:effectRef idx="2">
+            <a:schemeClr val="accent1"/>
+          </a:effectRef>
+          <a:fontRef idx="minor">
+            <a:schemeClr val="lt1"/>
+          </a:fontRef>
+        </p:style>
+        <p:txBody>
+          <a:bodyPr rtlCol="0" anchor="ctr"/>
+          <a:lstStyle/>
+          <a:p>
+            <a:pPr algn="ctr"/>
+          </a:p>
+        </p:txBody>
+      </p:sp>
+      <p:sp>
+        <p:nvSpPr>
+          <p:cNvPr id="32" name="Rectangle 31"/>
+          <p:cNvSpPr/>
+          <p:nvPr/>
+        </p:nvSpPr>
+        <p:spPr>
+          <a:xfrm>
+            <a:off x="594360" y="4169664"/>
+            <a:ext cx="73152" cy="1170432"/>
+          </a:xfrm>
+          <a:prstGeom prst="rect">
+            <a:avLst/>
+          </a:prstGeom>
+          <a:solidFill>
+            <a:srgbClr val="E4002B"/>
+          </a:solidFill>
+          <a:ln>
+            <a:noFill/>
+          </a:ln>
+        </p:spPr>
+        <p:style>
+          <a:lnRef idx="1">
+            <a:schemeClr val="accent1"/>
+          </a:lnRef>
+          <a:fillRef idx="3">
+            <a:schemeClr val="accent1"/>
+          </a:fillRef>
+          <a:effectRef idx="2">
+            <a:schemeClr val="accent1"/>
+          </a:effectRef>
+          <a:fontRef idx="minor">
+            <a:schemeClr val="lt1"/>
+          </a:fontRef>
+        </p:style>
+        <p:txBody>
+          <a:bodyPr rtlCol="0" anchor="ctr"/>
+          <a:lstStyle/>
+          <a:p>
+            <a:pPr algn="ctr"/>
+          </a:p>
+        </p:txBody>
+      </p:sp>
+      <p:sp>
+        <p:nvSpPr>
+          <p:cNvPr id="33" name="TextBox 32"/>
+          <p:cNvSpPr txBox="1"/>
+          <p:nvPr/>
+        </p:nvSpPr>
+        <p:spPr>
+          <a:xfrm>
+            <a:off x="777240" y="4279392"/>
+            <a:ext cx="3072384" cy="256032"/>
+          </a:xfrm>
+          <a:prstGeom prst="rect">
+            <a:avLst/>
+          </a:prstGeom>
+          <a:noFill/>
+        </p:spPr>
+        <p:txBody>
+          <a:bodyPr wrap="square" lIns="36576" rIns="36576" tIns="18288" bIns="18288">
+            <a:spAutoFit/>
+          </a:bodyPr>
+          <a:lstStyle/>
+          <a:p>
+            <a:pPr>
+              <a:defRPr sz="1130" b="1">
+                <a:solidFill>
+                  <a:srgbClr val="202020"/>
+                </a:solidFill>
+                <a:latin typeface="Arial"/>
+              </a:defRPr>
+            </a:pPr>
+            <a:r>
+              <a:t>Clinical protocols researched</a:t>
+            </a:r>
+          </a:p>
+        </p:txBody>
+      </p:sp>
+      <p:sp>
+        <p:nvSpPr>
+          <p:cNvPr id="34" name="TextBox 33"/>
+          <p:cNvSpPr txBox="1"/>
+          <p:nvPr/>
+        </p:nvSpPr>
+        <p:spPr>
+          <a:xfrm>
+            <a:off x="777240" y="4599432"/>
+            <a:ext cx="3054096" cy="685800"/>
+          </a:xfrm>
+          <a:prstGeom prst="rect">
+            <a:avLst/>
+          </a:prstGeom>
+          <a:noFill/>
+        </p:spPr>
+        <p:txBody>
+          <a:bodyPr wrap="square" lIns="0" rIns="18288" tIns="0">
+            <a:spAutoFit/>
+          </a:bodyPr>
+          <a:lstStyle/>
+          <a:p>
+            <a:pPr>
+              <a:defRPr sz="940">
+                <a:solidFill>
+                  <a:srgbClr val="36393F"/>
+                </a:solidFill>
+                <a:latin typeface="Arial"/>
+              </a:defRPr>
+            </a:pPr>
+            <a:r>
+              <a:t>Pre-surgical, post-cardiac, post-major surgery, emergency chest pain, arrhythmia, ICU/sepsis/shock monitoring.</a:t>
+            </a:r>
+          </a:p>
+        </p:txBody>
+      </p:sp>
+      <p:sp>
+        <p:nvSpPr>
+          <p:cNvPr id="35" name="Rectangle 34"/>
+          <p:cNvSpPr/>
+          <p:nvPr/>
+        </p:nvSpPr>
+        <p:spPr>
+          <a:xfrm>
+            <a:off x="4389120" y="4169664"/>
+            <a:ext cx="3364992" cy="1170432"/>
+          </a:xfrm>
+          <a:prstGeom prst="rect">
+            <a:avLst/>
+          </a:prstGeom>
+          <a:solidFill>
+            <a:srgbClr val="F3F4F6"/>
+          </a:solidFill>
+          <a:ln w="9525">
+            <a:solidFill>
+              <a:srgbClr val="E8EBEF"/>
+            </a:solidFill>
+          </a:ln>
+        </p:spPr>
+        <p:style>
+          <a:lnRef idx="1">
+            <a:schemeClr val="accent1"/>
+          </a:lnRef>
+          <a:fillRef idx="3">
+            <a:schemeClr val="accent1"/>
+          </a:fillRef>
+          <a:effectRef idx="2">
+            <a:schemeClr val="accent1"/>
+          </a:effectRef>
+          <a:fontRef idx="minor">
+            <a:schemeClr val="lt1"/>
+          </a:fontRef>
+        </p:style>
+        <p:txBody>
+          <a:bodyPr rtlCol="0" anchor="ctr"/>
+          <a:lstStyle/>
+          <a:p>
+            <a:pPr algn="ctr"/>
+          </a:p>
+        </p:txBody>
+      </p:sp>
+      <p:sp>
+        <p:nvSpPr>
+          <p:cNvPr id="36" name="Rectangle 35"/>
+          <p:cNvSpPr/>
+          <p:nvPr/>
+        </p:nvSpPr>
+        <p:spPr>
+          <a:xfrm>
+            <a:off x="4389120" y="4169664"/>
+            <a:ext cx="73152" cy="1170432"/>
+          </a:xfrm>
+          <a:prstGeom prst="rect">
+            <a:avLst/>
+          </a:prstGeom>
+          <a:solidFill>
+            <a:srgbClr val="202020"/>
+          </a:solidFill>
+          <a:ln>
+            <a:noFill/>
+          </a:ln>
+        </p:spPr>
+        <p:style>
+          <a:lnRef idx="1">
+            <a:schemeClr val="accent1"/>
+          </a:lnRef>
+          <a:fillRef idx="3">
+            <a:schemeClr val="accent1"/>
+          </a:fillRef>
+          <a:effectRef idx="2">
+            <a:schemeClr val="accent1"/>
+          </a:effectRef>
+          <a:fontRef idx="minor">
+            <a:schemeClr val="lt1"/>
+          </a:fontRef>
+        </p:style>
+        <p:txBody>
+          <a:bodyPr rtlCol="0" anchor="ctr"/>
+          <a:lstStyle/>
+          <a:p>
+            <a:pPr algn="ctr"/>
+          </a:p>
+        </p:txBody>
+      </p:sp>
+      <p:sp>
+        <p:nvSpPr>
+          <p:cNvPr id="37" name="TextBox 36"/>
+          <p:cNvSpPr txBox="1"/>
+          <p:nvPr/>
+        </p:nvSpPr>
+        <p:spPr>
+          <a:xfrm>
+            <a:off x="4572000" y="4279392"/>
+            <a:ext cx="3072384" cy="256032"/>
+          </a:xfrm>
+          <a:prstGeom prst="rect">
+            <a:avLst/>
+          </a:prstGeom>
+          <a:noFill/>
+        </p:spPr>
+        <p:txBody>
+          <a:bodyPr wrap="square" lIns="36576" rIns="36576" tIns="18288" bIns="18288">
+            <a:spAutoFit/>
+          </a:bodyPr>
+          <a:lstStyle/>
+          <a:p>
+            <a:pPr>
+              <a:defRPr sz="1130" b="1">
+                <a:solidFill>
+                  <a:srgbClr val="202020"/>
+                </a:solidFill>
+                <a:latin typeface="Arial"/>
+              </a:defRPr>
+            </a:pPr>
+            <a:r>
+              <a:t>Business case prepared</a:t>
+            </a:r>
+          </a:p>
+        </p:txBody>
+      </p:sp>
+      <p:sp>
+        <p:nvSpPr>
+          <p:cNvPr id="38" name="TextBox 37"/>
+          <p:cNvSpPr txBox="1"/>
+          <p:nvPr/>
+        </p:nvSpPr>
+        <p:spPr>
+          <a:xfrm>
+            <a:off x="4572000" y="4599432"/>
+            <a:ext cx="3054096" cy="685800"/>
+          </a:xfrm>
+          <a:prstGeom prst="rect">
+            <a:avLst/>
+          </a:prstGeom>
+          <a:noFill/>
+        </p:spPr>
+        <p:txBody>
+          <a:bodyPr wrap="square" lIns="0" rIns="18288" tIns="0">
+            <a:spAutoFit/>
+          </a:bodyPr>
+          <a:lstStyle/>
+          <a:p>
+            <a:pPr>
+              <a:defRPr sz="940">
+                <a:solidFill>
+                  <a:srgbClr val="36393F"/>
+                </a:solidFill>
+                <a:latin typeface="Arial"/>
+              </a:defRPr>
+            </a:pPr>
+            <a:r>
+              <a:t>Bed capacity, launch device assumptions, pricing rationale, lifecycle view, patient-charge positioning, benefit/cost framing.</a:t>
+            </a:r>
+          </a:p>
+        </p:txBody>
+      </p:sp>
+      <p:sp>
+        <p:nvSpPr>
+          <p:cNvPr id="39" name="Rectangle 38"/>
+          <p:cNvSpPr/>
+          <p:nvPr/>
+        </p:nvSpPr>
+        <p:spPr>
+          <a:xfrm>
+            <a:off x="8183880" y="4169664"/>
+            <a:ext cx="3364992" cy="1170432"/>
+          </a:xfrm>
+          <a:prstGeom prst="rect">
+            <a:avLst/>
+          </a:prstGeom>
+          <a:solidFill>
+            <a:srgbClr val="F3F4F6"/>
+          </a:solidFill>
+          <a:ln w="9525">
+            <a:solidFill>
+              <a:srgbClr val="E8EBEF"/>
+            </a:solidFill>
+          </a:ln>
+        </p:spPr>
+        <p:style>
+          <a:lnRef idx="1">
+            <a:schemeClr val="accent1"/>
+          </a:lnRef>
+          <a:fillRef idx="3">
+            <a:schemeClr val="accent1"/>
+          </a:fillRef>
+          <a:effectRef idx="2">
+            <a:schemeClr val="accent1"/>
+          </a:effectRef>
+          <a:fontRef idx="minor">
+            <a:schemeClr val="lt1"/>
+          </a:fontRef>
+        </p:style>
+        <p:txBody>
+          <a:bodyPr rtlCol="0" anchor="ctr"/>
+          <a:lstStyle/>
+          <a:p>
+            <a:pPr algn="ctr"/>
+          </a:p>
+        </p:txBody>
+      </p:sp>
+      <p:sp>
+        <p:nvSpPr>
+          <p:cNvPr id="40" name="Rectangle 39"/>
+          <p:cNvSpPr/>
+          <p:nvPr/>
+        </p:nvSpPr>
+        <p:spPr>
+          <a:xfrm>
+            <a:off x="8183880" y="4169664"/>
+            <a:ext cx="73152" cy="1170432"/>
+          </a:xfrm>
+          <a:prstGeom prst="rect">
+            <a:avLst/>
+          </a:prstGeom>
+          <a:solidFill>
+            <a:srgbClr val="E4002B"/>
+          </a:solidFill>
+          <a:ln>
+            <a:noFill/>
+          </a:ln>
+        </p:spPr>
+        <p:style>
+          <a:lnRef idx="1">
+            <a:schemeClr val="accent1"/>
+          </a:lnRef>
+          <a:fillRef idx="3">
+            <a:schemeClr val="accent1"/>
+          </a:fillRef>
+          <a:effectRef idx="2">
+            <a:schemeClr val="accent1"/>
+          </a:effectRef>
+          <a:fontRef idx="minor">
+            <a:schemeClr val="lt1"/>
+          </a:fontRef>
+        </p:style>
+        <p:txBody>
+          <a:bodyPr rtlCol="0" anchor="ctr"/>
+          <a:lstStyle/>
+          <a:p>
+            <a:pPr algn="ctr"/>
+          </a:p>
+        </p:txBody>
+      </p:sp>
+      <p:sp>
+        <p:nvSpPr>
+          <p:cNvPr id="41" name="TextBox 40"/>
+          <p:cNvSpPr txBox="1"/>
+          <p:nvPr/>
+        </p:nvSpPr>
+        <p:spPr>
+          <a:xfrm>
+            <a:off x="8366760" y="4279392"/>
+            <a:ext cx="3072384" cy="256032"/>
+          </a:xfrm>
+          <a:prstGeom prst="rect">
+            <a:avLst/>
+          </a:prstGeom>
+          <a:noFill/>
+        </p:spPr>
+        <p:txBody>
+          <a:bodyPr wrap="square" lIns="36576" rIns="36576" tIns="18288" bIns="18288">
+            <a:spAutoFit/>
+          </a:bodyPr>
+          <a:lstStyle/>
+          <a:p>
+            <a:pPr>
+              <a:defRPr sz="1130" b="1">
+                <a:solidFill>
+                  <a:srgbClr val="202020"/>
+                </a:solidFill>
+                <a:latin typeface="Arial"/>
+              </a:defRPr>
+            </a:pPr>
+            <a:r>
+              <a:t>MVO expansion path outlined</a:t>
+            </a:r>
+          </a:p>
+        </p:txBody>
+      </p:sp>
+      <p:sp>
+        <p:nvSpPr>
+          <p:cNvPr id="42" name="TextBox 41"/>
+          <p:cNvSpPr txBox="1"/>
+          <p:nvPr/>
+        </p:nvSpPr>
+        <p:spPr>
+          <a:xfrm>
+            <a:off x="8366760" y="4599432"/>
+            <a:ext cx="3054096" cy="685800"/>
+          </a:xfrm>
+          <a:prstGeom prst="rect">
+            <a:avLst/>
+          </a:prstGeom>
+          <a:noFill/>
+        </p:spPr>
+        <p:txBody>
+          <a:bodyPr wrap="square" lIns="0" rIns="18288" tIns="0">
+            <a:spAutoFit/>
+          </a:bodyPr>
+          <a:lstStyle/>
+          <a:p>
+            <a:pPr>
+              <a:defRPr sz="940">
+                <a:solidFill>
+                  <a:srgbClr val="36393F"/>
+                </a:solidFill>
+                <a:latin typeface="Arial"/>
+              </a:defRPr>
+            </a:pPr>
+            <a:r>
+              <a:t>MVO1 foundation toward respiration rate, HRV, posture, IPX4, and SpO2 expansion.</a:t>
+            </a:r>
+          </a:p>
+        </p:txBody>
+      </p:sp>
+      <p:sp>
+        <p:nvSpPr>
+          <p:cNvPr id="43" name="Rectangle 42"/>
+          <p:cNvSpPr/>
+          <p:nvPr/>
+        </p:nvSpPr>
+        <p:spPr>
+          <a:xfrm>
+            <a:off x="0" y="6510528"/>
+            <a:ext cx="12191695" cy="36576"/>
+          </a:xfrm>
+          <a:prstGeom prst="rect">
+            <a:avLst/>
+          </a:prstGeom>
+          <a:solidFill>
+            <a:srgbClr val="E4002B"/>
+          </a:solidFill>
+          <a:ln>
+            <a:noFill/>
+          </a:ln>
+        </p:spPr>
+        <p:style>
+          <a:lnRef idx="1">
+            <a:schemeClr val="accent1"/>
+          </a:lnRef>
+          <a:fillRef idx="3">
+            <a:schemeClr val="accent1"/>
+          </a:fillRef>
+          <a:effectRef idx="2">
+            <a:schemeClr val="accent1"/>
+          </a:effectRef>
+          <a:fontRef idx="minor">
+            <a:schemeClr val="lt1"/>
+          </a:fontRef>
+        </p:style>
+        <p:txBody>
+          <a:bodyPr rtlCol="0" anchor="ctr"/>
+          <a:lstStyle/>
+          <a:p>
+            <a:pPr algn="ctr"/>
+          </a:p>
+        </p:txBody>
+      </p:sp>
+      <p:sp>
+        <p:nvSpPr>
+          <p:cNvPr id="44" name="TextBox 43"/>
+          <p:cNvSpPr txBox="1"/>
+          <p:nvPr/>
+        </p:nvSpPr>
+        <p:spPr>
+          <a:xfrm>
+            <a:off x="475488" y="6601968"/>
+            <a:ext cx="2926080" cy="164592"/>
+          </a:xfrm>
+          <a:prstGeom prst="rect">
+            <a:avLst/>
+          </a:prstGeom>
+          <a:noFill/>
+        </p:spPr>
+        <p:txBody>
+          <a:bodyPr wrap="square" lIns="36576" rIns="36576" tIns="18288" bIns="18288">
+            <a:spAutoFit/>
+          </a:bodyPr>
+          <a:lstStyle/>
+          <a:p>
+            <a:pPr>
+              <a:defRPr sz="950" b="1">
+                <a:solidFill>
+                  <a:srgbClr val="63666A"/>
+                </a:solidFill>
+                <a:latin typeface="Arial"/>
+              </a:defRPr>
+            </a:pPr>
+            <a:r>
+              <a:t>Impact by Honeywell</a:t>
+            </a:r>
+          </a:p>
+        </p:txBody>
+      </p:sp>
+      <p:sp>
+        <p:nvSpPr>
+          <p:cNvPr id="45" name="TextBox 44"/>
+          <p:cNvSpPr txBox="1"/>
+          <p:nvPr/>
+        </p:nvSpPr>
+        <p:spPr>
+          <a:xfrm>
+            <a:off x="3063240" y="6601968"/>
+            <a:ext cx="6400800" cy="164592"/>
+          </a:xfrm>
+          <a:prstGeom prst="rect">
+            <a:avLst/>
+          </a:prstGeom>
+          <a:noFill/>
+        </p:spPr>
+        <p:txBody>
+          <a:bodyPr wrap="square" lIns="36576" rIns="36576" tIns="18288" bIns="18288">
+            <a:spAutoFit/>
+          </a:bodyPr>
+          <a:lstStyle/>
+          <a:p>
+            <a:pPr>
+              <a:defRPr sz="950" b="0">
+                <a:solidFill>
+                  <a:srgbClr val="63666A"/>
+                </a:solidFill>
+                <a:latin typeface="Arial"/>
+              </a:defRPr>
+            </a:pPr>
+            <a:r>
+              <a:t>Technical Architecture Version | India and APAC Innovation Challenge - Phase 2</a:t>
+            </a:r>
+          </a:p>
+        </p:txBody>
+      </p:sp>
+      <p:sp>
+        <p:nvSpPr>
+          <p:cNvPr id="46" name="TextBox 45"/>
+          <p:cNvSpPr txBox="1"/>
+          <p:nvPr/>
+        </p:nvSpPr>
+        <p:spPr>
+          <a:xfrm>
+            <a:off x="11201400" y="6601968"/>
+            <a:ext cx="502920" cy="164592"/>
+          </a:xfrm>
+          <a:prstGeom prst="rect">
+            <a:avLst/>
+          </a:prstGeom>
+          <a:noFill/>
+        </p:spPr>
+        <p:txBody>
+          <a:bodyPr wrap="square" lIns="36576" rIns="36576" tIns="18288" bIns="18288">
+            <a:spAutoFit/>
+          </a:bodyPr>
+          <a:lstStyle/>
+          <a:p>
+            <a:pPr algn="r">
+              <a:defRPr sz="950" b="0">
+                <a:solidFill>
+                  <a:srgbClr val="63666A"/>
+                </a:solidFill>
+                <a:latin typeface="Arial"/>
+              </a:defRPr>
+            </a:pPr>
+            <a:r>
+              <a:t>19</a:t>
+            </a:r>
+          </a:p>
+        </p:txBody>
+      </p:sp>
+    </p:spTree>
+  </p:cSld>
+  <p:clrMapOvr>
+    <a:masterClrMapping/>
+  </p:clrMapOvr>
+</p:sld>
+</file>
+
 <file path=ppt/slides/slide2.xml><?xml version="1.0" encoding="utf-8"?>
 <p:sld xmlns:a="http://schemas.openxmlformats.org/drawingml/2006/main" xmlns:p="http://schemas.openxmlformats.org/presentationml/2006/main" xmlns:r="http://schemas.openxmlformats.org/officeDocument/2006/relationships">
   <p:cSld>
@@ -16524,7 +18336,7 @@
               </a:defRPr>
             </a:pPr>
             <a:r>
-              <a:t>Existing visual baseline</a:t>
+              <a:t>WSP foundation already achieved</a:t>
             </a:r>
           </a:p>
         </p:txBody>
@@ -16560,7 +18372,7 @@
               </a:defRPr>
             </a:pPr>
             <a:r>
-              <a:t>Images reused from WSP source decks</a:t>
+              <a:t>Prototype, concept, and hardware visuals already documented</a:t>
             </a:r>
           </a:p>
         </p:txBody>

</xml_diff>